<commit_message>
Took out queries in controllers and added notes for adding products.
</commit_message>
<xml_diff>
--- a/Invex_Presentation.pptx
+++ b/Invex_Presentation.pptx
@@ -5,7 +5,7 @@
     <p:sldMasterId id="2147483648" r:id="rId1"/>
   </p:sldMasterIdLst>
   <p:notesMasterIdLst>
-    <p:notesMasterId r:id="rId12"/>
+    <p:notesMasterId r:id="rId11"/>
   </p:notesMasterIdLst>
   <p:sldIdLst>
     <p:sldId id="256" r:id="rId2"/>
@@ -17,7 +17,6 @@
     <p:sldId id="262" r:id="rId8"/>
     <p:sldId id="263" r:id="rId9"/>
     <p:sldId id="264" r:id="rId10"/>
-    <p:sldId id="265" r:id="rId11"/>
   </p:sldIdLst>
   <p:sldSz cx="9144000" cy="5143500" type="screen16x9"/>
   <p:notesSz cx="5143500" cy="9144000"/>
@@ -312,90 +311,6 @@
             <a:fld id="{F7021451-1387-4CA6-816F-3879F97B5CBC}" type="slidenum">
               <a:rPr lang="en-US"/>
               <a:t>1</a:t>
-            </a:fld>
-            <a:endParaRPr lang="en-US"/>
-          </a:p>
-        </p:txBody>
-      </p:sp>
-    </p:spTree>
-    <p:extLst>
-      <p:ext uri="{BB962C8B-B14F-4D97-AF65-F5344CB8AC3E}">
-        <p14:creationId xmlns:p14="http://schemas.microsoft.com/office/powerpoint/2010/main" val="1024086991"/>
-      </p:ext>
-    </p:extLst>
-  </p:cSld>
-  <p:clrMapOvr>
-    <a:masterClrMapping/>
-  </p:clrMapOvr>
-</p:notes>
-</file>
-
-<file path=ppt/notesSlides/notesSlide10.xml><?xml version="1.0" encoding="utf-8"?>
-<p:notes xmlns:a="http://schemas.openxmlformats.org/drawingml/2006/main" xmlns:r="http://schemas.openxmlformats.org/officeDocument/2006/relationships" xmlns:p="http://schemas.openxmlformats.org/presentationml/2006/main">
-  <p:cSld>
-    <p:spTree>
-      <p:nvGrpSpPr>
-        <p:cNvPr id="1" name=""/>
-        <p:cNvGrpSpPr/>
-        <p:nvPr/>
-      </p:nvGrpSpPr>
-      <p:grpSpPr>
-        <a:xfrm>
-          <a:off x="0" y="0"/>
-          <a:ext cx="0" cy="0"/>
-          <a:chOff x="0" y="0"/>
-          <a:chExt cx="0" cy="0"/>
-        </a:xfrm>
-      </p:grpSpPr>
-      <p:sp>
-        <p:nvSpPr>
-          <p:cNvPr id="2" name="Slide Image Placeholder 1"/>
-          <p:cNvSpPr>
-            <a:spLocks noGrp="1" noRot="1" noChangeAspect="1"/>
-          </p:cNvSpPr>
-          <p:nvPr>
-            <p:ph type="sldImg"/>
-          </p:nvPr>
-        </p:nvSpPr>
-        <p:spPr/>
-      </p:sp>
-      <p:sp>
-        <p:nvSpPr>
-          <p:cNvPr id="3" name="Notes Placeholder 2"/>
-          <p:cNvSpPr>
-            <a:spLocks noGrp="1"/>
-          </p:cNvSpPr>
-          <p:nvPr>
-            <p:ph type="body" idx="1"/>
-          </p:nvPr>
-        </p:nvSpPr>
-        <p:spPr/>
-        <p:txBody>
-          <a:bodyPr/>
-          <a:lstStyle/>
-          <a:p>
-            <a:endParaRPr lang="en-US" dirty="0"/>
-          </a:p>
-        </p:txBody>
-      </p:sp>
-      <p:sp>
-        <p:nvSpPr>
-          <p:cNvPr id="4" name="Slide Number Placeholder 3"/>
-          <p:cNvSpPr>
-            <a:spLocks noGrp="1"/>
-          </p:cNvSpPr>
-          <p:nvPr>
-            <p:ph type="sldNum" sz="quarter" idx="10"/>
-          </p:nvPr>
-        </p:nvSpPr>
-        <p:spPr/>
-        <p:txBody>
-          <a:bodyPr/>
-          <a:lstStyle/>
-          <a:p>
-            <a:fld id="{F7021451-1387-4CA6-816F-3879F97B5CBC}" type="slidenum">
-              <a:rPr lang="en-US"/>
-              <a:t>10</a:t>
             </a:fld>
             <a:endParaRPr lang="en-US"/>
           </a:p>
@@ -1983,241 +1898,6 @@
 </p:sld>
 </file>
 
-<file path=ppt/slides/slide10.xml><?xml version="1.0" encoding="utf-8"?>
-<p:sld xmlns:a="http://schemas.openxmlformats.org/drawingml/2006/main" xmlns:r="http://schemas.openxmlformats.org/officeDocument/2006/relationships" xmlns:p="http://schemas.openxmlformats.org/presentationml/2006/main">
-  <p:cSld name="Slide 10">
-    <p:bg>
-      <p:bgPr>
-        <a:solidFill>
-          <a:srgbClr val="0A0A0B"/>
-        </a:solidFill>
-        <a:effectLst/>
-      </p:bgPr>
-    </p:bg>
-    <p:spTree>
-      <p:nvGrpSpPr>
-        <p:cNvPr id="1" name=""/>
-        <p:cNvGrpSpPr/>
-        <p:nvPr/>
-      </p:nvGrpSpPr>
-      <p:grpSpPr>
-        <a:xfrm>
-          <a:off x="0" y="0"/>
-          <a:ext cx="0" cy="0"/>
-          <a:chOff x="0" y="0"/>
-          <a:chExt cx="0" cy="0"/>
-        </a:xfrm>
-      </p:grpSpPr>
-      <p:sp>
-        <p:nvSpPr>
-          <p:cNvPr id="2" name="Shape 0"/>
-          <p:cNvSpPr/>
-          <p:nvPr/>
-        </p:nvSpPr>
-        <p:spPr>
-          <a:xfrm>
-            <a:off x="-1371600" y="-1371600"/>
-            <a:ext cx="3474720" cy="3474720"/>
-          </a:xfrm>
-          <a:prstGeom prst="ellipse">
-            <a:avLst/>
-          </a:prstGeom>
-          <a:solidFill>
-            <a:srgbClr val="F87171">
-              <a:alpha val="6000"/>
-            </a:srgbClr>
-          </a:solidFill>
-          <a:ln/>
-        </p:spPr>
-        <p:txBody>
-          <a:bodyPr/>
-          <a:lstStyle/>
-          <a:p>
-            <a:endParaRPr lang="en-US"/>
-          </a:p>
-        </p:txBody>
-      </p:sp>
-      <p:sp>
-        <p:nvSpPr>
-          <p:cNvPr id="3" name="Shape 1"/>
-          <p:cNvSpPr/>
-          <p:nvPr/>
-        </p:nvSpPr>
-        <p:spPr>
-          <a:xfrm>
-            <a:off x="6949440" y="4023360"/>
-            <a:ext cx="3291840" cy="3291840"/>
-          </a:xfrm>
-          <a:prstGeom prst="ellipse">
-            <a:avLst/>
-          </a:prstGeom>
-          <a:solidFill>
-            <a:srgbClr val="8CA0FF">
-              <a:alpha val="4000"/>
-            </a:srgbClr>
-          </a:solidFill>
-          <a:ln/>
-        </p:spPr>
-        <p:txBody>
-          <a:bodyPr/>
-          <a:lstStyle/>
-          <a:p>
-            <a:endParaRPr lang="en-US"/>
-          </a:p>
-        </p:txBody>
-      </p:sp>
-      <p:sp>
-        <p:nvSpPr>
-          <p:cNvPr id="4" name="Text 2"/>
-          <p:cNvSpPr/>
-          <p:nvPr/>
-        </p:nvSpPr>
-        <p:spPr>
-          <a:xfrm>
-            <a:off x="548640" y="1691640"/>
-            <a:ext cx="8046720" cy="1645920"/>
-          </a:xfrm>
-          <a:prstGeom prst="rect">
-            <a:avLst/>
-          </a:prstGeom>
-          <a:noFill/>
-          <a:ln/>
-        </p:spPr>
-        <p:txBody>
-          <a:bodyPr wrap="square" lIns="0" tIns="0" rIns="0" bIns="0" rtlCol="0" anchor="ctr"/>
-          <a:lstStyle/>
-          <a:p>
-            <a:pPr marL="0" indent="0" algn="ctr">
-              <a:buNone/>
-            </a:pPr>
-            <a:r>
-              <a:rPr lang="en-US" sz="13000" b="1" dirty="0">
-                <a:solidFill>
-                  <a:srgbClr val="F5F5F7"/>
-                </a:solidFill>
-                <a:latin typeface="Calibri" pitchFamily="34" charset="0"/>
-                <a:ea typeface="Calibri" pitchFamily="34" charset="-122"/>
-                <a:cs typeface="Calibri" pitchFamily="34" charset="-120"/>
-              </a:rPr>
-              <a:t>Q &amp; A</a:t>
-            </a:r>
-            <a:endParaRPr lang="en-US" sz="13000" dirty="0"/>
-          </a:p>
-        </p:txBody>
-      </p:sp>
-      <p:sp>
-        <p:nvSpPr>
-          <p:cNvPr id="5" name="Shape 3"/>
-          <p:cNvSpPr/>
-          <p:nvPr/>
-        </p:nvSpPr>
-        <p:spPr>
-          <a:xfrm>
-            <a:off x="4498848" y="3611880"/>
-            <a:ext cx="146304" cy="146304"/>
-          </a:xfrm>
-          <a:prstGeom prst="ellipse">
-            <a:avLst/>
-          </a:prstGeom>
-          <a:solidFill>
-            <a:srgbClr val="F87171"/>
-          </a:solidFill>
-          <a:ln/>
-        </p:spPr>
-        <p:txBody>
-          <a:bodyPr/>
-          <a:lstStyle/>
-          <a:p>
-            <a:endParaRPr lang="en-US"/>
-          </a:p>
-        </p:txBody>
-      </p:sp>
-      <p:sp>
-        <p:nvSpPr>
-          <p:cNvPr id="6" name="Text 4"/>
-          <p:cNvSpPr/>
-          <p:nvPr/>
-        </p:nvSpPr>
-        <p:spPr>
-          <a:xfrm>
-            <a:off x="548640" y="3840480"/>
-            <a:ext cx="8046720" cy="365760"/>
-          </a:xfrm>
-          <a:prstGeom prst="rect">
-            <a:avLst/>
-          </a:prstGeom>
-          <a:noFill/>
-          <a:ln/>
-        </p:spPr>
-        <p:txBody>
-          <a:bodyPr wrap="square" lIns="0" tIns="0" rIns="0" bIns="0" rtlCol="0" anchor="ctr"/>
-          <a:lstStyle/>
-          <a:p>
-            <a:pPr marL="0" indent="0" algn="ctr">
-              <a:buNone/>
-            </a:pPr>
-            <a:r>
-              <a:rPr lang="en-US" sz="1800" dirty="0">
-                <a:solidFill>
-                  <a:srgbClr val="B4B4B8"/>
-                </a:solidFill>
-                <a:latin typeface="Calibri" pitchFamily="34" charset="0"/>
-                <a:ea typeface="Calibri" pitchFamily="34" charset="-122"/>
-                <a:cs typeface="Calibri" pitchFamily="34" charset="-120"/>
-              </a:rPr>
-              <a:t>Thank you for listening.</a:t>
-            </a:r>
-            <a:endParaRPr lang="en-US" sz="1800" dirty="0"/>
-          </a:p>
-        </p:txBody>
-      </p:sp>
-      <p:sp>
-        <p:nvSpPr>
-          <p:cNvPr id="7" name="Text 5"/>
-          <p:cNvSpPr/>
-          <p:nvPr/>
-        </p:nvSpPr>
-        <p:spPr>
-          <a:xfrm>
-            <a:off x="548640" y="4846320"/>
-            <a:ext cx="8046720" cy="228600"/>
-          </a:xfrm>
-          <a:prstGeom prst="rect">
-            <a:avLst/>
-          </a:prstGeom>
-          <a:noFill/>
-          <a:ln/>
-        </p:spPr>
-        <p:txBody>
-          <a:bodyPr wrap="square" lIns="0" tIns="0" rIns="0" bIns="0" rtlCol="0" anchor="ctr"/>
-          <a:lstStyle/>
-          <a:p>
-            <a:pPr marL="0" indent="0" algn="ctr">
-              <a:buNone/>
-            </a:pPr>
-            <a:r>
-              <a:rPr lang="en-US" sz="900" kern="0" spc="400" dirty="0">
-                <a:solidFill>
-                  <a:srgbClr val="5A5A5F"/>
-                </a:solidFill>
-                <a:latin typeface="Consolas" pitchFamily="34" charset="0"/>
-                <a:ea typeface="Consolas" pitchFamily="34" charset="-122"/>
-                <a:cs typeface="Consolas" pitchFamily="34" charset="-120"/>
-              </a:rPr>
-              <a:t>INVEX  ·  Inventory Management System</a:t>
-            </a:r>
-            <a:endParaRPr lang="en-US" sz="900" dirty="0"/>
-          </a:p>
-        </p:txBody>
-      </p:sp>
-    </p:spTree>
-  </p:cSld>
-  <p:clrMapOvr>
-    <a:masterClrMapping/>
-  </p:clrMapOvr>
-</p:sld>
-</file>
-
 <file path=ppt/slides/slide2.xml><?xml version="1.0" encoding="utf-8"?>
 <p:sld xmlns:a="http://schemas.openxmlformats.org/drawingml/2006/main" xmlns:r="http://schemas.openxmlformats.org/officeDocument/2006/relationships" xmlns:p="http://schemas.openxmlformats.org/presentationml/2006/main">
   <p:cSld name="Slide 2">
@@ -6626,7 +6306,7 @@
         </p:nvSpPr>
         <p:spPr>
           <a:xfrm>
-            <a:off x="-1371600" y="-1371600"/>
+            <a:off x="-1448602" y="-1700784"/>
             <a:ext cx="3474720" cy="3474720"/>
           </a:xfrm>
           <a:prstGeom prst="ellipse">
@@ -7201,7 +6881,7 @@
                 <a:ea typeface="Consolas" pitchFamily="34" charset="-122"/>
                 <a:cs typeface="Consolas" pitchFamily="34" charset="-120"/>
               </a:rPr>
-              <a:t>Auth</a:t>
+              <a:t>Middleware</a:t>
             </a:r>
             <a:endParaRPr lang="en-US" sz="1100" dirty="0"/>
           </a:p>

</xml_diff>